<commit_message>
refactor: v2.0.0 generalize to discrete manufacturing
</commit_message>
<xml_diff>
--- a/01-精益工具知识库/PPT/02-TPM与OEE详解.pptx
+++ b/01-精益工具知识库/PPT/02-TPM与OEE详解.pptx
@@ -1337,6 +1337,10 @@
             <a:prstDash val="solid"/>
           </a:ln>
         </p:spPr>
+        <p:txBody>
+          <a:bodyPr/>
+          <a:p/>
+        </p:txBody>
       </p:sp>
       <p:sp>
         <p:nvSpPr>
@@ -1362,6 +1366,10 @@
             <a:prstDash val="solid"/>
           </a:ln>
         </p:spPr>
+        <p:txBody>
+          <a:bodyPr/>
+          <a:p/>
+        </p:txBody>
       </p:sp>
       <p:sp>
         <p:nvSpPr>
@@ -1387,6 +1395,10 @@
             <a:prstDash val="solid"/>
           </a:ln>
         </p:spPr>
+        <p:txBody>
+          <a:bodyPr/>
+          <a:p/>
+        </p:txBody>
       </p:sp>
       <p:sp>
         <p:nvSpPr>
@@ -1412,6 +1424,10 @@
             <a:prstDash val="solid"/>
           </a:ln>
         </p:spPr>
+        <p:txBody>
+          <a:bodyPr/>
+          <a:p/>
+        </p:txBody>
       </p:sp>
       <p:sp>
         <p:nvSpPr>
@@ -1437,6 +1453,10 @@
             <a:prstDash val="solid"/>
           </a:ln>
         </p:spPr>
+        <p:txBody>
+          <a:bodyPr/>
+          <a:p/>
+        </p:txBody>
       </p:sp>
       <p:sp>
         <p:nvSpPr>
@@ -1579,6 +1599,10 @@
             <a:prstDash val="solid"/>
           </a:ln>
         </p:spPr>
+        <p:txBody>
+          <a:bodyPr/>
+          <a:p/>
+        </p:txBody>
       </p:sp>
       <p:sp>
         <p:nvSpPr>
@@ -1668,6 +1692,10 @@
             <a:prstDash val="solid"/>
           </a:ln>
         </p:spPr>
+        <p:txBody>
+          <a:bodyPr/>
+          <a:p/>
+        </p:txBody>
       </p:sp>
       <p:sp>
         <p:nvSpPr>
@@ -1693,6 +1721,10 @@
             <a:prstDash val="solid"/>
           </a:ln>
         </p:spPr>
+        <p:txBody>
+          <a:bodyPr/>
+          <a:p/>
+        </p:txBody>
       </p:sp>
       <p:sp>
         <p:nvSpPr>
@@ -1718,6 +1750,10 @@
             <a:prstDash val="solid"/>
           </a:ln>
         </p:spPr>
+        <p:txBody>
+          <a:bodyPr/>
+          <a:p/>
+        </p:txBody>
       </p:sp>
       <p:sp>
         <p:nvSpPr>
@@ -1818,6 +1854,10 @@
           </a:solidFill>
           <a:ln/>
         </p:spPr>
+        <p:txBody>
+          <a:bodyPr/>
+          <a:p/>
+        </p:txBody>
       </p:sp>
       <p:sp>
         <p:nvSpPr>
@@ -1886,6 +1926,10 @@
             </a:outerShdw>
           </a:effectLst>
         </p:spPr>
+        <p:txBody>
+          <a:bodyPr/>
+          <a:p/>
+        </p:txBody>
       </p:sp>
       <p:sp>
         <p:nvSpPr>
@@ -1911,6 +1955,10 @@
             <a:prstDash val="solid"/>
           </a:ln>
         </p:spPr>
+        <p:txBody>
+          <a:bodyPr/>
+          <a:p/>
+        </p:txBody>
       </p:sp>
       <p:sp>
         <p:nvSpPr>
@@ -2113,6 +2161,10 @@
             </a:outerShdw>
           </a:effectLst>
         </p:spPr>
+        <p:txBody>
+          <a:bodyPr/>
+          <a:p/>
+        </p:txBody>
       </p:sp>
       <p:sp>
         <p:nvSpPr>
@@ -2138,6 +2190,10 @@
             <a:prstDash val="solid"/>
           </a:ln>
         </p:spPr>
+        <p:txBody>
+          <a:bodyPr/>
+          <a:p/>
+        </p:txBody>
       </p:sp>
       <p:sp>
         <p:nvSpPr>
@@ -2340,6 +2396,10 @@
             </a:outerShdw>
           </a:effectLst>
         </p:spPr>
+        <p:txBody>
+          <a:bodyPr/>
+          <a:p/>
+        </p:txBody>
       </p:sp>
       <p:sp>
         <p:nvSpPr>
@@ -2365,6 +2425,10 @@
             <a:prstDash val="solid"/>
           </a:ln>
         </p:spPr>
+        <p:txBody>
+          <a:bodyPr/>
+          <a:p/>
+        </p:txBody>
       </p:sp>
       <p:sp>
         <p:nvSpPr>
@@ -2560,6 +2624,10 @@
           </a:solidFill>
           <a:ln/>
         </p:spPr>
+        <p:txBody>
+          <a:bodyPr/>
+          <a:p/>
+        </p:txBody>
       </p:sp>
       <p:sp>
         <p:nvSpPr>
@@ -2624,6 +2692,10 @@
             <a:prstDash val="solid"/>
           </a:ln>
         </p:spPr>
+        <p:txBody>
+          <a:bodyPr/>
+          <a:p/>
+        </p:txBody>
       </p:sp>
       <p:sp>
         <p:nvSpPr>
@@ -2713,6 +2785,10 @@
             <a:prstDash val="solid"/>
           </a:ln>
         </p:spPr>
+        <p:txBody>
+          <a:bodyPr/>
+          <a:p/>
+        </p:txBody>
       </p:sp>
       <p:sp>
         <p:nvSpPr>
@@ -2738,6 +2814,10 @@
             <a:prstDash val="solid"/>
           </a:ln>
         </p:spPr>
+        <p:txBody>
+          <a:bodyPr/>
+          <a:p/>
+        </p:txBody>
       </p:sp>
       <p:sp>
         <p:nvSpPr>
@@ -2763,6 +2843,10 @@
             <a:prstDash val="solid"/>
           </a:ln>
         </p:spPr>
+        <p:txBody>
+          <a:bodyPr/>
+          <a:p/>
+        </p:txBody>
       </p:sp>
       <p:sp>
         <p:nvSpPr>
@@ -2870,6 +2954,10 @@
             </a:outerShdw>
           </a:effectLst>
         </p:spPr>
+        <p:txBody>
+          <a:bodyPr/>
+          <a:p/>
+        </p:txBody>
       </p:sp>
       <p:sp>
         <p:nvSpPr>
@@ -2895,6 +2983,10 @@
             <a:prstDash val="solid"/>
           </a:ln>
         </p:spPr>
+        <p:txBody>
+          <a:bodyPr/>
+          <a:p/>
+        </p:txBody>
       </p:sp>
       <p:sp>
         <p:nvSpPr>
@@ -3073,6 +3165,10 @@
           </a:solidFill>
           <a:ln/>
         </p:spPr>
+        <p:txBody>
+          <a:bodyPr/>
+          <a:p/>
+        </p:txBody>
       </p:sp>
       <p:sp>
         <p:nvSpPr>
@@ -3095,6 +3191,10 @@
           </a:solidFill>
           <a:ln/>
         </p:spPr>
+        <p:txBody>
+          <a:bodyPr/>
+          <a:p/>
+        </p:txBody>
       </p:sp>
       <p:sp>
         <p:nvSpPr>
@@ -3129,7 +3229,7 @@
                 <a:ea typeface="Arial" pitchFamily="34" charset="-122"/>
                 <a:cs typeface="Arial" pitchFamily="34" charset="-120"/>
               </a:rPr>
-              <a:t>紧固件行业重点：减少故障和换型损失可显著提升OEE</a:t>
+              <a:t>制造业重点：减少故障和换型损失可显著提升OEE</a:t>
             </a:r>
             <a:endParaRPr lang="en-US" sz="850" dirty="0"/>
           </a:p>
@@ -3163,6 +3263,10 @@
             </a:outerShdw>
           </a:effectLst>
         </p:spPr>
+        <p:txBody>
+          <a:bodyPr/>
+          <a:p/>
+        </p:txBody>
       </p:sp>
       <p:sp>
         <p:nvSpPr>
@@ -3188,6 +3292,10 @@
             <a:prstDash val="solid"/>
           </a:ln>
         </p:spPr>
+        <p:txBody>
+          <a:bodyPr/>
+          <a:p/>
+        </p:txBody>
       </p:sp>
       <p:sp>
         <p:nvSpPr>
@@ -3366,6 +3474,10 @@
           </a:solidFill>
           <a:ln/>
         </p:spPr>
+        <p:txBody>
+          <a:bodyPr/>
+          <a:p/>
+        </p:txBody>
       </p:sp>
       <p:sp>
         <p:nvSpPr>
@@ -3388,6 +3500,10 @@
           </a:solidFill>
           <a:ln/>
         </p:spPr>
+        <p:txBody>
+          <a:bodyPr/>
+          <a:p/>
+        </p:txBody>
       </p:sp>
       <p:sp>
         <p:nvSpPr>
@@ -3422,7 +3538,7 @@
                 <a:ea typeface="Arial" pitchFamily="34" charset="-122"/>
                 <a:cs typeface="Arial" pitchFamily="34" charset="-120"/>
               </a:rPr>
-              <a:t>紧固件行业重点：减少故障和换型损失可显著提升OEE</a:t>
+              <a:t>制造业重点：减少故障和换型损失可显著提升OEE</a:t>
             </a:r>
             <a:endParaRPr lang="en-US" sz="850" dirty="0"/>
           </a:p>
@@ -3456,6 +3572,10 @@
             </a:outerShdw>
           </a:effectLst>
         </p:spPr>
+        <p:txBody>
+          <a:bodyPr/>
+          <a:p/>
+        </p:txBody>
       </p:sp>
       <p:sp>
         <p:nvSpPr>
@@ -3481,6 +3601,10 @@
             <a:prstDash val="solid"/>
           </a:ln>
         </p:spPr>
+        <p:txBody>
+          <a:bodyPr/>
+          <a:p/>
+        </p:txBody>
       </p:sp>
       <p:sp>
         <p:nvSpPr>
@@ -3659,6 +3783,10 @@
           </a:solidFill>
           <a:ln/>
         </p:spPr>
+        <p:txBody>
+          <a:bodyPr/>
+          <a:p/>
+        </p:txBody>
       </p:sp>
       <p:sp>
         <p:nvSpPr>
@@ -3681,6 +3809,10 @@
           </a:solidFill>
           <a:ln/>
         </p:spPr>
+        <p:txBody>
+          <a:bodyPr/>
+          <a:p/>
+        </p:txBody>
       </p:sp>
       <p:sp>
         <p:nvSpPr>
@@ -3715,7 +3847,7 @@
                 <a:ea typeface="Arial" pitchFamily="34" charset="-122"/>
                 <a:cs typeface="Arial" pitchFamily="34" charset="-120"/>
               </a:rPr>
-              <a:t>紧固件行业重点：减少故障和换型损失可显著提升OEE</a:t>
+              <a:t>制造业重点：减少故障和换型损失可显著提升OEE</a:t>
             </a:r>
             <a:endParaRPr lang="en-US" sz="850" dirty="0"/>
           </a:p>
@@ -3749,6 +3881,10 @@
             </a:outerShdw>
           </a:effectLst>
         </p:spPr>
+        <p:txBody>
+          <a:bodyPr/>
+          <a:p/>
+        </p:txBody>
       </p:sp>
       <p:sp>
         <p:nvSpPr>
@@ -3774,6 +3910,10 @@
             <a:prstDash val="solid"/>
           </a:ln>
         </p:spPr>
+        <p:txBody>
+          <a:bodyPr/>
+          <a:p/>
+        </p:txBody>
       </p:sp>
       <p:sp>
         <p:nvSpPr>
@@ -3952,6 +4092,10 @@
           </a:solidFill>
           <a:ln/>
         </p:spPr>
+        <p:txBody>
+          <a:bodyPr/>
+          <a:p/>
+        </p:txBody>
       </p:sp>
       <p:sp>
         <p:nvSpPr>
@@ -3974,6 +4118,10 @@
           </a:solidFill>
           <a:ln/>
         </p:spPr>
+        <p:txBody>
+          <a:bodyPr/>
+          <a:p/>
+        </p:txBody>
       </p:sp>
       <p:sp>
         <p:nvSpPr>
@@ -4008,7 +4156,7 @@
                 <a:ea typeface="Arial" pitchFamily="34" charset="-122"/>
                 <a:cs typeface="Arial" pitchFamily="34" charset="-120"/>
               </a:rPr>
-              <a:t>紧固件行业重点：减少故障和换型损失可显著提升OEE</a:t>
+              <a:t>制造业重点：减少故障和换型损失可显著提升OEE</a:t>
             </a:r>
             <a:endParaRPr lang="en-US" sz="850" dirty="0"/>
           </a:p>
@@ -4042,6 +4190,10 @@
             </a:outerShdw>
           </a:effectLst>
         </p:spPr>
+        <p:txBody>
+          <a:bodyPr/>
+          <a:p/>
+        </p:txBody>
       </p:sp>
       <p:sp>
         <p:nvSpPr>
@@ -4067,6 +4219,10 @@
             <a:prstDash val="solid"/>
           </a:ln>
         </p:spPr>
+        <p:txBody>
+          <a:bodyPr/>
+          <a:p/>
+        </p:txBody>
       </p:sp>
       <p:sp>
         <p:nvSpPr>
@@ -4245,6 +4401,10 @@
           </a:solidFill>
           <a:ln/>
         </p:spPr>
+        <p:txBody>
+          <a:bodyPr/>
+          <a:p/>
+        </p:txBody>
       </p:sp>
       <p:sp>
         <p:nvSpPr>
@@ -4267,6 +4427,10 @@
           </a:solidFill>
           <a:ln/>
         </p:spPr>
+        <p:txBody>
+          <a:bodyPr/>
+          <a:p/>
+        </p:txBody>
       </p:sp>
       <p:sp>
         <p:nvSpPr>
@@ -4301,7 +4465,7 @@
                 <a:ea typeface="Arial" pitchFamily="34" charset="-122"/>
                 <a:cs typeface="Arial" pitchFamily="34" charset="-120"/>
               </a:rPr>
-              <a:t>紧固件行业重点：减少故障和换型损失可显著提升OEE</a:t>
+              <a:t>制造业重点：减少故障和换型损失可显著提升OEE</a:t>
             </a:r>
             <a:endParaRPr lang="en-US" sz="850" dirty="0"/>
           </a:p>
@@ -4335,6 +4499,10 @@
             </a:outerShdw>
           </a:effectLst>
         </p:spPr>
+        <p:txBody>
+          <a:bodyPr/>
+          <a:p/>
+        </p:txBody>
       </p:sp>
       <p:sp>
         <p:nvSpPr>
@@ -4360,6 +4528,10 @@
             <a:prstDash val="solid"/>
           </a:ln>
         </p:spPr>
+        <p:txBody>
+          <a:bodyPr/>
+          <a:p/>
+        </p:txBody>
       </p:sp>
       <p:sp>
         <p:nvSpPr>
@@ -4538,6 +4710,10 @@
           </a:solidFill>
           <a:ln/>
         </p:spPr>
+        <p:txBody>
+          <a:bodyPr/>
+          <a:p/>
+        </p:txBody>
       </p:sp>
       <p:sp>
         <p:nvSpPr>
@@ -4560,6 +4736,10 @@
           </a:solidFill>
           <a:ln/>
         </p:spPr>
+        <p:txBody>
+          <a:bodyPr/>
+          <a:p/>
+        </p:txBody>
       </p:sp>
       <p:sp>
         <p:nvSpPr>
@@ -4594,7 +4774,7 @@
                 <a:ea typeface="Arial" pitchFamily="34" charset="-122"/>
                 <a:cs typeface="Arial" pitchFamily="34" charset="-120"/>
               </a:rPr>
-              <a:t>紧固件行业重点：减少故障和换型损失可显著提升OEE</a:t>
+              <a:t>制造业重点：减少故障和换型损失可显著提升OEE</a:t>
             </a:r>
             <a:endParaRPr lang="en-US" sz="850" dirty="0"/>
           </a:p>
@@ -4624,6 +4804,10 @@
             <a:prstDash val="solid"/>
           </a:ln>
         </p:spPr>
+        <p:txBody>
+          <a:bodyPr/>
+          <a:p/>
+        </p:txBody>
       </p:sp>
       <p:sp>
         <p:nvSpPr>
@@ -4713,6 +4897,10 @@
             <a:prstDash val="solid"/>
           </a:ln>
         </p:spPr>
+        <p:txBody>
+          <a:bodyPr/>
+          <a:p/>
+        </p:txBody>
       </p:sp>
       <p:sp>
         <p:nvSpPr>
@@ -4738,6 +4926,10 @@
             <a:prstDash val="solid"/>
           </a:ln>
         </p:spPr>
+        <p:txBody>
+          <a:bodyPr/>
+          <a:p/>
+        </p:txBody>
       </p:sp>
       <p:sp>
         <p:nvSpPr>
@@ -4763,6 +4955,10 @@
             <a:prstDash val="solid"/>
           </a:ln>
         </p:spPr>
+        <p:txBody>
+          <a:bodyPr/>
+          <a:p/>
+        </p:txBody>
       </p:sp>
       <p:sp>
         <p:nvSpPr>
@@ -4870,6 +5066,10 @@
             </a:outerShdw>
           </a:effectLst>
         </p:spPr>
+        <p:txBody>
+          <a:bodyPr/>
+          <a:p/>
+        </p:txBody>
       </p:sp>
       <p:sp>
         <p:nvSpPr>
@@ -4895,6 +5095,10 @@
             <a:prstDash val="solid"/>
           </a:ln>
         </p:spPr>
+        <p:txBody>
+          <a:bodyPr/>
+          <a:p/>
+        </p:txBody>
       </p:sp>
       <p:sp>
         <p:nvSpPr>
@@ -5037,6 +5241,10 @@
             <a:prstDash val="solid"/>
           </a:ln>
         </p:spPr>
+        <p:txBody>
+          <a:bodyPr/>
+          <a:p/>
+        </p:txBody>
       </p:sp>
       <p:sp>
         <p:nvSpPr>
@@ -5105,6 +5313,10 @@
             </a:outerShdw>
           </a:effectLst>
         </p:spPr>
+        <p:txBody>
+          <a:bodyPr/>
+          <a:p/>
+        </p:txBody>
       </p:sp>
       <p:sp>
         <p:nvSpPr>
@@ -5130,6 +5342,10 @@
             <a:prstDash val="solid"/>
           </a:ln>
         </p:spPr>
+        <p:txBody>
+          <a:bodyPr/>
+          <a:p/>
+        </p:txBody>
       </p:sp>
       <p:sp>
         <p:nvSpPr>
@@ -5272,6 +5488,10 @@
             <a:prstDash val="solid"/>
           </a:ln>
         </p:spPr>
+        <p:txBody>
+          <a:bodyPr/>
+          <a:p/>
+        </p:txBody>
       </p:sp>
       <p:sp>
         <p:nvSpPr>
@@ -5340,6 +5560,10 @@
             </a:outerShdw>
           </a:effectLst>
         </p:spPr>
+        <p:txBody>
+          <a:bodyPr/>
+          <a:p/>
+        </p:txBody>
       </p:sp>
       <p:sp>
         <p:nvSpPr>
@@ -5365,6 +5589,10 @@
             <a:prstDash val="solid"/>
           </a:ln>
         </p:spPr>
+        <p:txBody>
+          <a:bodyPr/>
+          <a:p/>
+        </p:txBody>
       </p:sp>
       <p:sp>
         <p:nvSpPr>
@@ -5507,6 +5735,10 @@
             <a:prstDash val="solid"/>
           </a:ln>
         </p:spPr>
+        <p:txBody>
+          <a:bodyPr/>
+          <a:p/>
+        </p:txBody>
       </p:sp>
       <p:sp>
         <p:nvSpPr>
@@ -5575,6 +5807,10 @@
             </a:outerShdw>
           </a:effectLst>
         </p:spPr>
+        <p:txBody>
+          <a:bodyPr/>
+          <a:p/>
+        </p:txBody>
       </p:sp>
       <p:sp>
         <p:nvSpPr>
@@ -5600,6 +5836,10 @@
             <a:prstDash val="solid"/>
           </a:ln>
         </p:spPr>
+        <p:txBody>
+          <a:bodyPr/>
+          <a:p/>
+        </p:txBody>
       </p:sp>
       <p:sp>
         <p:nvSpPr>
@@ -5742,6 +5982,10 @@
             <a:prstDash val="solid"/>
           </a:ln>
         </p:spPr>
+        <p:txBody>
+          <a:bodyPr/>
+          <a:p/>
+        </p:txBody>
       </p:sp>
       <p:sp>
         <p:nvSpPr>
@@ -5810,6 +6054,10 @@
             </a:outerShdw>
           </a:effectLst>
         </p:spPr>
+        <p:txBody>
+          <a:bodyPr/>
+          <a:p/>
+        </p:txBody>
       </p:sp>
       <p:sp>
         <p:nvSpPr>
@@ -5835,6 +6083,10 @@
             <a:prstDash val="solid"/>
           </a:ln>
         </p:spPr>
+        <p:txBody>
+          <a:bodyPr/>
+          <a:p/>
+        </p:txBody>
       </p:sp>
       <p:sp>
         <p:nvSpPr>
@@ -5977,6 +6229,10 @@
             <a:prstDash val="solid"/>
           </a:ln>
         </p:spPr>
+        <p:txBody>
+          <a:bodyPr/>
+          <a:p/>
+        </p:txBody>
       </p:sp>
       <p:sp>
         <p:nvSpPr>
@@ -6045,6 +6301,10 @@
             </a:outerShdw>
           </a:effectLst>
         </p:spPr>
+        <p:txBody>
+          <a:bodyPr/>
+          <a:p/>
+        </p:txBody>
       </p:sp>
       <p:sp>
         <p:nvSpPr>
@@ -6070,6 +6330,10 @@
             <a:prstDash val="solid"/>
           </a:ln>
         </p:spPr>
+        <p:txBody>
+          <a:bodyPr/>
+          <a:p/>
+        </p:txBody>
       </p:sp>
       <p:sp>
         <p:nvSpPr>
@@ -6212,6 +6476,10 @@
             <a:prstDash val="solid"/>
           </a:ln>
         </p:spPr>
+        <p:txBody>
+          <a:bodyPr/>
+          <a:p/>
+        </p:txBody>
       </p:sp>
       <p:sp>
         <p:nvSpPr>
@@ -6280,6 +6548,10 @@
             </a:outerShdw>
           </a:effectLst>
         </p:spPr>
+        <p:txBody>
+          <a:bodyPr/>
+          <a:p/>
+        </p:txBody>
       </p:sp>
       <p:sp>
         <p:nvSpPr>
@@ -6305,6 +6577,10 @@
             <a:prstDash val="solid"/>
           </a:ln>
         </p:spPr>
+        <p:txBody>
+          <a:bodyPr/>
+          <a:p/>
+        </p:txBody>
       </p:sp>
       <p:sp>
         <p:nvSpPr>
@@ -6447,6 +6723,10 @@
             <a:prstDash val="solid"/>
           </a:ln>
         </p:spPr>
+        <p:txBody>
+          <a:bodyPr/>
+          <a:p/>
+        </p:txBody>
       </p:sp>
       <p:sp>
         <p:nvSpPr>
@@ -6515,6 +6795,10 @@
             </a:outerShdw>
           </a:effectLst>
         </p:spPr>
+        <p:txBody>
+          <a:bodyPr/>
+          <a:p/>
+        </p:txBody>
       </p:sp>
       <p:sp>
         <p:nvSpPr>
@@ -6540,6 +6824,10 @@
             <a:prstDash val="solid"/>
           </a:ln>
         </p:spPr>
+        <p:txBody>
+          <a:bodyPr/>
+          <a:p/>
+        </p:txBody>
       </p:sp>
       <p:sp>
         <p:nvSpPr>
@@ -6682,6 +6970,10 @@
             <a:prstDash val="solid"/>
           </a:ln>
         </p:spPr>
+        <p:txBody>
+          <a:bodyPr/>
+          <a:p/>
+        </p:txBody>
       </p:sp>
       <p:sp>
         <p:nvSpPr>
@@ -6746,6 +7038,10 @@
             <a:prstDash val="solid"/>
           </a:ln>
         </p:spPr>
+        <p:txBody>
+          <a:bodyPr/>
+          <a:p/>
+        </p:txBody>
       </p:sp>
       <p:sp>
         <p:nvSpPr>
@@ -6835,6 +7131,10 @@
             <a:prstDash val="solid"/>
           </a:ln>
         </p:spPr>
+        <p:txBody>
+          <a:bodyPr/>
+          <a:p/>
+        </p:txBody>
       </p:sp>
       <p:sp>
         <p:nvSpPr>
@@ -6860,6 +7160,10 @@
             <a:prstDash val="solid"/>
           </a:ln>
         </p:spPr>
+        <p:txBody>
+          <a:bodyPr/>
+          <a:p/>
+        </p:txBody>
       </p:sp>
       <p:sp>
         <p:nvSpPr>
@@ -6885,6 +7189,10 @@
             <a:prstDash val="solid"/>
           </a:ln>
         </p:spPr>
+        <p:txBody>
+          <a:bodyPr/>
+          <a:p/>
+        </p:txBody>
       </p:sp>
       <p:sp>
         <p:nvSpPr>
@@ -6985,6 +7293,10 @@
           </a:solidFill>
           <a:ln/>
         </p:spPr>
+        <p:txBody>
+          <a:bodyPr/>
+          <a:p/>
+        </p:txBody>
       </p:sp>
       <p:sp>
         <p:nvSpPr>
@@ -7066,6 +7378,10 @@
             <a:prstDash val="solid"/>
           </a:ln>
         </p:spPr>
+        <p:txBody>
+          <a:bodyPr/>
+          <a:p/>
+        </p:txBody>
       </p:sp>
       <p:sp>
         <p:nvSpPr>
@@ -7091,6 +7407,10 @@
             <a:prstDash val="solid"/>
           </a:ln>
         </p:spPr>
+        <p:txBody>
+          <a:bodyPr/>
+          <a:p/>
+        </p:txBody>
       </p:sp>
       <p:sp>
         <p:nvSpPr>
@@ -7113,6 +7433,10 @@
           </a:solidFill>
           <a:ln/>
         </p:spPr>
+        <p:txBody>
+          <a:bodyPr/>
+          <a:p/>
+        </p:txBody>
       </p:sp>
       <p:sp>
         <p:nvSpPr>
@@ -7194,6 +7518,10 @@
             <a:prstDash val="solid"/>
           </a:ln>
         </p:spPr>
+        <p:txBody>
+          <a:bodyPr/>
+          <a:p/>
+        </p:txBody>
       </p:sp>
       <p:sp>
         <p:nvSpPr>
@@ -7219,6 +7547,10 @@
             <a:prstDash val="solid"/>
           </a:ln>
         </p:spPr>
+        <p:txBody>
+          <a:bodyPr/>
+          <a:p/>
+        </p:txBody>
       </p:sp>
       <p:sp>
         <p:nvSpPr>
@@ -7241,6 +7573,10 @@
           </a:solidFill>
           <a:ln/>
         </p:spPr>
+        <p:txBody>
+          <a:bodyPr/>
+          <a:p/>
+        </p:txBody>
       </p:sp>
       <p:sp>
         <p:nvSpPr>
@@ -7322,6 +7658,10 @@
             <a:prstDash val="solid"/>
           </a:ln>
         </p:spPr>
+        <p:txBody>
+          <a:bodyPr/>
+          <a:p/>
+        </p:txBody>
       </p:sp>
       <p:sp>
         <p:nvSpPr>
@@ -7347,6 +7687,10 @@
             <a:prstDash val="solid"/>
           </a:ln>
         </p:spPr>
+        <p:txBody>
+          <a:bodyPr/>
+          <a:p/>
+        </p:txBody>
       </p:sp>
       <p:sp>
         <p:nvSpPr>
@@ -7369,6 +7713,10 @@
           </a:solidFill>
           <a:ln/>
         </p:spPr>
+        <p:txBody>
+          <a:bodyPr/>
+          <a:p/>
+        </p:txBody>
       </p:sp>
       <p:sp>
         <p:nvSpPr>
@@ -7450,6 +7798,10 @@
             <a:prstDash val="solid"/>
           </a:ln>
         </p:spPr>
+        <p:txBody>
+          <a:bodyPr/>
+          <a:p/>
+        </p:txBody>
       </p:sp>
       <p:sp>
         <p:nvSpPr>
@@ -7475,6 +7827,10 @@
             <a:prstDash val="solid"/>
           </a:ln>
         </p:spPr>
+        <p:txBody>
+          <a:bodyPr/>
+          <a:p/>
+        </p:txBody>
       </p:sp>
       <p:sp>
         <p:nvSpPr>
@@ -7497,6 +7853,10 @@
           </a:solidFill>
           <a:ln/>
         </p:spPr>
+        <p:txBody>
+          <a:bodyPr/>
+          <a:p/>
+        </p:txBody>
       </p:sp>
       <p:sp>
         <p:nvSpPr>
@@ -7578,6 +7938,10 @@
             <a:prstDash val="solid"/>
           </a:ln>
         </p:spPr>
+        <p:txBody>
+          <a:bodyPr/>
+          <a:p/>
+        </p:txBody>
       </p:sp>
       <p:sp>
         <p:nvSpPr>
@@ -7603,6 +7967,10 @@
             <a:prstDash val="solid"/>
           </a:ln>
         </p:spPr>
+        <p:txBody>
+          <a:bodyPr/>
+          <a:p/>
+        </p:txBody>
       </p:sp>
       <p:sp>
         <p:nvSpPr>
@@ -7625,6 +7993,10 @@
           </a:solidFill>
           <a:ln/>
         </p:spPr>
+        <p:txBody>
+          <a:bodyPr/>
+          <a:p/>
+        </p:txBody>
       </p:sp>
       <p:sp>
         <p:nvSpPr>
@@ -7706,6 +8078,10 @@
             <a:prstDash val="solid"/>
           </a:ln>
         </p:spPr>
+        <p:txBody>
+          <a:bodyPr/>
+          <a:p/>
+        </p:txBody>
       </p:sp>
       <p:sp>
         <p:nvSpPr>
@@ -7731,6 +8107,10 @@
             <a:prstDash val="solid"/>
           </a:ln>
         </p:spPr>
+        <p:txBody>
+          <a:bodyPr/>
+          <a:p/>
+        </p:txBody>
       </p:sp>
       <p:sp>
         <p:nvSpPr>
@@ -7753,6 +8133,10 @@
           </a:solidFill>
           <a:ln/>
         </p:spPr>
+        <p:txBody>
+          <a:bodyPr/>
+          <a:p/>
+        </p:txBody>
       </p:sp>
       <p:sp>
         <p:nvSpPr>
@@ -7831,6 +8215,10 @@
           </a:solidFill>
           <a:ln/>
         </p:spPr>
+        <p:txBody>
+          <a:bodyPr/>
+          <a:p/>
+        </p:txBody>
       </p:sp>
       <p:sp>
         <p:nvSpPr>
@@ -7892,6 +8280,10 @@
           </a:solidFill>
           <a:ln/>
         </p:spPr>
+        <p:txBody>
+          <a:bodyPr/>
+          <a:p/>
+        </p:txBody>
       </p:sp>
       <p:sp>
         <p:nvSpPr>
@@ -7953,6 +8345,10 @@
           </a:solidFill>
           <a:ln/>
         </p:spPr>
+        <p:txBody>
+          <a:bodyPr/>
+          <a:p/>
+        </p:txBody>
       </p:sp>
       <p:sp>
         <p:nvSpPr>
@@ -8014,6 +8410,10 @@
           </a:solidFill>
           <a:ln/>
         </p:spPr>
+        <p:txBody>
+          <a:bodyPr/>
+          <a:p/>
+        </p:txBody>
       </p:sp>
       <p:sp>
         <p:nvSpPr>
@@ -8075,6 +8475,10 @@
           </a:solidFill>
           <a:ln/>
         </p:spPr>
+        <p:txBody>
+          <a:bodyPr/>
+          <a:p/>
+        </p:txBody>
       </p:sp>
       <p:sp>
         <p:nvSpPr>
@@ -8136,6 +8540,10 @@
           </a:solidFill>
           <a:ln/>
         </p:spPr>
+        <p:txBody>
+          <a:bodyPr/>
+          <a:p/>
+        </p:txBody>
       </p:sp>
       <p:sp>
         <p:nvSpPr>
@@ -8197,6 +8605,10 @@
           </a:solidFill>
           <a:ln/>
         </p:spPr>
+        <p:txBody>
+          <a:bodyPr/>
+          <a:p/>
+        </p:txBody>
       </p:sp>
       <p:sp>
         <p:nvSpPr>
@@ -8258,6 +8670,10 @@
           </a:solidFill>
           <a:ln/>
         </p:spPr>
+        <p:txBody>
+          <a:bodyPr/>
+          <a:p/>
+        </p:txBody>
       </p:sp>
       <p:sp>
         <p:nvSpPr>
@@ -8319,6 +8735,10 @@
           </a:solidFill>
           <a:ln/>
         </p:spPr>
+        <p:txBody>
+          <a:bodyPr/>
+          <a:p/>
+        </p:txBody>
       </p:sp>
       <p:sp>
         <p:nvSpPr>
@@ -8380,6 +8800,10 @@
           </a:solidFill>
           <a:ln/>
         </p:spPr>
+        <p:txBody>
+          <a:bodyPr/>
+          <a:p/>
+        </p:txBody>
       </p:sp>
       <p:sp>
         <p:nvSpPr>
@@ -8483,6 +8907,10 @@
             <a:prstDash val="solid"/>
           </a:ln>
         </p:spPr>
+        <p:txBody>
+          <a:bodyPr/>
+          <a:p/>
+        </p:txBody>
       </p:sp>
       <p:sp>
         <p:nvSpPr>
@@ -8572,6 +9000,10 @@
             <a:prstDash val="solid"/>
           </a:ln>
         </p:spPr>
+        <p:txBody>
+          <a:bodyPr/>
+          <a:p/>
+        </p:txBody>
       </p:sp>
       <p:sp>
         <p:nvSpPr>
@@ -8597,6 +9029,10 @@
             <a:prstDash val="solid"/>
           </a:ln>
         </p:spPr>
+        <p:txBody>
+          <a:bodyPr/>
+          <a:p/>
+        </p:txBody>
       </p:sp>
       <p:sp>
         <p:nvSpPr>
@@ -8622,6 +9058,10 @@
             <a:prstDash val="solid"/>
           </a:ln>
         </p:spPr>
+        <p:txBody>
+          <a:bodyPr/>
+          <a:p/>
+        </p:txBody>
       </p:sp>
       <p:sp>
         <p:nvSpPr>
@@ -8656,7 +9096,7 @@
                 <a:ea typeface="Arial Black" pitchFamily="34" charset="-122"/>
                 <a:cs typeface="Arial Black" pitchFamily="34" charset="-120"/>
               </a:rPr>
-              <a:t>OEE 行业基准与紧固件KPI</a:t>
+              <a:t>OEE 行业基准与产品KPI</a:t>
             </a:r>
             <a:endParaRPr lang="en-US" sz="2800" dirty="0"/>
           </a:p>
@@ -8695,7 +9135,7 @@
                 <a:ea typeface="Arial" pitchFamily="34" charset="-122"/>
                 <a:cs typeface="Arial" pitchFamily="34" charset="-120"/>
               </a:rPr>
-              <a:t>OEE Benchmarks &amp; Fastener KPIs</a:t>
+              <a:t>OEE Benchmarks &amp; Manufacturing KPIs</a:t>
             </a:r>
             <a:endParaRPr lang="en-US" sz="1400" dirty="0"/>
           </a:p>
@@ -8727,6 +9167,10 @@
             <a:prstDash val="solid"/>
           </a:ln>
         </p:spPr>
+        <p:txBody>
+          <a:bodyPr/>
+          <a:p/>
+        </p:txBody>
       </p:sp>
       <p:sp>
         <p:nvSpPr>
@@ -8752,6 +9196,10 @@
             <a:prstDash val="solid"/>
           </a:ln>
         </p:spPr>
+        <p:txBody>
+          <a:bodyPr/>
+          <a:p/>
+        </p:txBody>
       </p:sp>
       <p:sp>
         <p:nvSpPr>
@@ -8913,6 +9361,10 @@
             <a:prstDash val="solid"/>
           </a:ln>
         </p:spPr>
+        <p:txBody>
+          <a:bodyPr/>
+          <a:p/>
+        </p:txBody>
       </p:sp>
       <p:sp>
         <p:nvSpPr>
@@ -8938,6 +9390,10 @@
             <a:prstDash val="solid"/>
           </a:ln>
         </p:spPr>
+        <p:txBody>
+          <a:bodyPr/>
+          <a:p/>
+        </p:txBody>
       </p:sp>
       <p:sp>
         <p:nvSpPr>
@@ -9099,6 +9555,10 @@
             <a:prstDash val="solid"/>
           </a:ln>
         </p:spPr>
+        <p:txBody>
+          <a:bodyPr/>
+          <a:p/>
+        </p:txBody>
       </p:sp>
       <p:sp>
         <p:nvSpPr>
@@ -9124,6 +9584,10 @@
             <a:prstDash val="solid"/>
           </a:ln>
         </p:spPr>
+        <p:txBody>
+          <a:bodyPr/>
+          <a:p/>
+        </p:txBody>
       </p:sp>
       <p:sp>
         <p:nvSpPr>
@@ -9285,6 +9749,10 @@
             <a:prstDash val="solid"/>
           </a:ln>
         </p:spPr>
+        <p:txBody>
+          <a:bodyPr/>
+          <a:p/>
+        </p:txBody>
       </p:sp>
       <p:sp>
         <p:nvSpPr>
@@ -9310,6 +9778,10 @@
             <a:prstDash val="solid"/>
           </a:ln>
         </p:spPr>
+        <p:txBody>
+          <a:bodyPr/>
+          <a:p/>
+        </p:txBody>
       </p:sp>
       <p:sp>
         <p:nvSpPr>
@@ -9469,6 +9941,10 @@
             <a:prstDash val="solid"/>
           </a:ln>
         </p:spPr>
+        <p:txBody>
+          <a:bodyPr/>
+          <a:p/>
+        </p:txBody>
       </p:sp>
       <p:sp>
         <p:nvSpPr>
@@ -9503,7 +9979,7 @@
                 <a:ea typeface="Arial Black" pitchFamily="34" charset="-122"/>
                 <a:cs typeface="Arial Black" pitchFamily="34" charset="-120"/>
               </a:rPr>
-              <a:t>紧固件制造关键KPI</a:t>
+              <a:t>制造关键KPI</a:t>
             </a:r>
             <a:endParaRPr lang="en-US" sz="1800" dirty="0"/>
           </a:p>
@@ -9528,6 +10004,10 @@
           </a:solidFill>
           <a:ln/>
         </p:spPr>
+        <p:txBody>
+          <a:bodyPr/>
+          <a:p/>
+        </p:txBody>
       </p:sp>
       <p:sp>
         <p:nvSpPr>
@@ -9587,6 +10067,10 @@
           </a:solidFill>
           <a:ln/>
         </p:spPr>
+        <p:txBody>
+          <a:bodyPr/>
+          <a:p/>
+        </p:txBody>
       </p:sp>
       <p:sp>
         <p:nvSpPr>
@@ -9646,6 +10130,10 @@
           </a:solidFill>
           <a:ln/>
         </p:spPr>
+        <p:txBody>
+          <a:bodyPr/>
+          <a:p/>
+        </p:txBody>
       </p:sp>
       <p:sp>
         <p:nvSpPr>
@@ -9705,6 +10193,10 @@
           </a:solidFill>
           <a:ln/>
         </p:spPr>
+        <p:txBody>
+          <a:bodyPr/>
+          <a:p/>
+        </p:txBody>
       </p:sp>
       <p:sp>
         <p:nvSpPr>
@@ -9764,6 +10256,10 @@
           </a:solidFill>
           <a:ln/>
         </p:spPr>
+        <p:txBody>
+          <a:bodyPr/>
+          <a:p/>
+        </p:txBody>
       </p:sp>
       <p:sp>
         <p:nvSpPr>
@@ -9823,6 +10319,10 @@
           </a:solidFill>
           <a:ln/>
         </p:spPr>
+        <p:txBody>
+          <a:bodyPr/>
+          <a:p/>
+        </p:txBody>
       </p:sp>
       <p:sp>
         <p:nvSpPr>
@@ -9882,6 +10382,10 @@
           </a:solidFill>
           <a:ln/>
         </p:spPr>
+        <p:txBody>
+          <a:bodyPr/>
+          <a:p/>
+        </p:txBody>
       </p:sp>
       <p:sp>
         <p:nvSpPr>
@@ -9941,6 +10445,10 @@
           </a:solidFill>
           <a:ln/>
         </p:spPr>
+        <p:txBody>
+          <a:bodyPr/>
+          <a:p/>
+        </p:txBody>
       </p:sp>
       <p:sp>
         <p:nvSpPr>
@@ -10000,6 +10508,10 @@
           </a:solidFill>
           <a:ln/>
         </p:spPr>
+        <p:txBody>
+          <a:bodyPr/>
+          <a:p/>
+        </p:txBody>
       </p:sp>
       <p:sp>
         <p:nvSpPr>
@@ -10059,6 +10571,10 @@
           </a:solidFill>
           <a:ln/>
         </p:spPr>
+        <p:txBody>
+          <a:bodyPr/>
+          <a:p/>
+        </p:txBody>
       </p:sp>
       <p:sp>
         <p:nvSpPr>
@@ -10118,6 +10634,10 @@
           </a:solidFill>
           <a:ln/>
         </p:spPr>
+        <p:txBody>
+          <a:bodyPr/>
+          <a:p/>
+        </p:txBody>
       </p:sp>
       <p:sp>
         <p:nvSpPr>
@@ -10177,6 +10697,10 @@
           </a:solidFill>
           <a:ln/>
         </p:spPr>
+        <p:txBody>
+          <a:bodyPr/>
+          <a:p/>
+        </p:txBody>
       </p:sp>
       <p:sp>
         <p:nvSpPr>
@@ -10236,6 +10760,10 @@
           </a:solidFill>
           <a:ln/>
         </p:spPr>
+        <p:txBody>
+          <a:bodyPr/>
+          <a:p/>
+        </p:txBody>
       </p:sp>
       <p:sp>
         <p:nvSpPr>
@@ -10295,6 +10823,10 @@
           </a:solidFill>
           <a:ln/>
         </p:spPr>
+        <p:txBody>
+          <a:bodyPr/>
+          <a:p/>
+        </p:txBody>
       </p:sp>
       <p:sp>
         <p:nvSpPr>
@@ -10354,6 +10886,10 @@
           </a:solidFill>
           <a:ln/>
         </p:spPr>
+        <p:txBody>
+          <a:bodyPr/>
+          <a:p/>
+        </p:txBody>
       </p:sp>
       <p:sp>
         <p:nvSpPr>
@@ -10413,6 +10949,10 @@
           </a:solidFill>
           <a:ln/>
         </p:spPr>
+        <p:txBody>
+          <a:bodyPr/>
+          <a:p/>
+        </p:txBody>
       </p:sp>
       <p:sp>
         <p:nvSpPr>
@@ -10472,6 +11012,10 @@
           </a:solidFill>
           <a:ln/>
         </p:spPr>
+        <p:txBody>
+          <a:bodyPr/>
+          <a:p/>
+        </p:txBody>
       </p:sp>
       <p:sp>
         <p:nvSpPr>
@@ -10531,6 +11075,10 @@
           </a:solidFill>
           <a:ln/>
         </p:spPr>
+        <p:txBody>
+          <a:bodyPr/>
+          <a:p/>
+        </p:txBody>
       </p:sp>
       <p:sp>
         <p:nvSpPr>
@@ -10590,6 +11138,10 @@
           </a:solidFill>
           <a:ln/>
         </p:spPr>
+        <p:txBody>
+          <a:bodyPr/>
+          <a:p/>
+        </p:txBody>
       </p:sp>
       <p:sp>
         <p:nvSpPr>
@@ -10649,6 +11201,10 @@
           </a:solidFill>
           <a:ln/>
         </p:spPr>
+        <p:txBody>
+          <a:bodyPr/>
+          <a:p/>
+        </p:txBody>
       </p:sp>
       <p:sp>
         <p:nvSpPr>
@@ -10708,6 +11264,10 @@
           </a:solidFill>
           <a:ln/>
         </p:spPr>
+        <p:txBody>
+          <a:bodyPr/>
+          <a:p/>
+        </p:txBody>
       </p:sp>
       <p:sp>
         <p:nvSpPr>
@@ -10767,6 +11327,10 @@
           </a:solidFill>
           <a:ln/>
         </p:spPr>
+        <p:txBody>
+          <a:bodyPr/>
+          <a:p/>
+        </p:txBody>
       </p:sp>
       <p:sp>
         <p:nvSpPr>
@@ -10826,6 +11390,10 @@
           </a:solidFill>
           <a:ln/>
         </p:spPr>
+        <p:txBody>
+          <a:bodyPr/>
+          <a:p/>
+        </p:txBody>
       </p:sp>
       <p:sp>
         <p:nvSpPr>
@@ -10885,6 +11453,10 @@
           </a:solidFill>
           <a:ln/>
         </p:spPr>
+        <p:txBody>
+          <a:bodyPr/>
+          <a:p/>
+        </p:txBody>
       </p:sp>
       <p:sp>
         <p:nvSpPr>
@@ -10949,6 +11521,10 @@
             <a:prstDash val="solid"/>
           </a:ln>
         </p:spPr>
+        <p:txBody>
+          <a:bodyPr/>
+          <a:p/>
+        </p:txBody>
       </p:sp>
       <p:sp>
         <p:nvSpPr>
@@ -10983,7 +11559,7 @@
                 <a:ea typeface="Arial" pitchFamily="34" charset="-122"/>
                 <a:cs typeface="Arial" pitchFamily="34" charset="-120"/>
               </a:rPr>
-              <a:t>OEE从72%提升至85%是紧固件企业3年精益转型的核心目标</a:t>
+              <a:t>OEE从72%提升至85%是制造企业3年精益转型的核心目标</a:t>
             </a:r>
             <a:endParaRPr lang="en-US" sz="1100" dirty="0"/>
           </a:p>

</xml_diff>